<commit_message>
Quartz sync: Nov 30, 2025, 11:29 PM
</commit_message>
<xml_diff>
--- a/content/Articles/session41tokens.pptx
+++ b/content/Articles/session41tokens.pptx
@@ -116,7 +116,7 @@
 <file path=ppt/revisionInfo.xml><?xml version="1.0" encoding="utf-8"?>
 <p1510:revInfo xmlns:a="http://schemas.openxmlformats.org/drawingml/2006/main" xmlns:r="http://schemas.openxmlformats.org/officeDocument/2006/relationships" xmlns:p1510="http://schemas.microsoft.com/office/powerpoint/2015/10/main">
   <p1510:revLst>
-    <p1510:client id="{44AFAF80-F569-4769-87CB-1732BFD48783}" v="47" dt="2025-11-11T06:32:10.926"/>
+    <p1510:client id="{44AFAF80-F569-4769-87CB-1732BFD48783}" v="58" dt="2025-11-11T18:16:30.671"/>
   </p1510:revLst>
 </p1510:revInfo>
 </file>
@@ -126,12 +126,12 @@
   <pc:docChgLst>
     <pc:chgData name="Jack Bond" userId="d0613b4d9d68792d" providerId="LiveId" clId="{DAEA3D54-AD02-4E1B-A73A-AB467D915B21}"/>
     <pc:docChg chg="undo custSel addSld delSld modSld sldOrd">
-      <pc:chgData name="Jack Bond" userId="d0613b4d9d68792d" providerId="LiveId" clId="{DAEA3D54-AD02-4E1B-A73A-AB467D915B21}" dt="2025-11-11T06:32:23.399" v="764" actId="1076"/>
+      <pc:chgData name="Jack Bond" userId="d0613b4d9d68792d" providerId="LiveId" clId="{DAEA3D54-AD02-4E1B-A73A-AB467D915B21}" dt="2025-11-11T18:16:30.668" v="778" actId="1076"/>
       <pc:docMkLst>
         <pc:docMk/>
       </pc:docMkLst>
       <pc:sldChg chg="addSp delSp modSp new mod">
-        <pc:chgData name="Jack Bond" userId="d0613b4d9d68792d" providerId="LiveId" clId="{DAEA3D54-AD02-4E1B-A73A-AB467D915B21}" dt="2025-11-11T06:32:23.399" v="764" actId="1076"/>
+        <pc:chgData name="Jack Bond" userId="d0613b4d9d68792d" providerId="LiveId" clId="{DAEA3D54-AD02-4E1B-A73A-AB467D915B21}" dt="2025-11-11T18:16:30.668" v="778" actId="1076"/>
         <pc:sldMkLst>
           <pc:docMk/>
           <pc:sldMk cId="3346064594" sldId="274"/>
@@ -161,7 +161,7 @@
           </ac:grpSpMkLst>
         </pc:grpChg>
         <pc:picChg chg="add mod modCrop">
-          <ac:chgData name="Jack Bond" userId="d0613b4d9d68792d" providerId="LiveId" clId="{DAEA3D54-AD02-4E1B-A73A-AB467D915B21}" dt="2025-11-11T06:24:45.044" v="757" actId="1076"/>
+          <ac:chgData name="Jack Bond" userId="d0613b4d9d68792d" providerId="LiveId" clId="{DAEA3D54-AD02-4E1B-A73A-AB467D915B21}" dt="2025-11-11T18:16:17.057" v="770" actId="1076"/>
           <ac:picMkLst>
             <pc:docMk/>
             <pc:sldMk cId="3346064594" sldId="274"/>
@@ -185,7 +185,7 @@
           </ac:picMkLst>
         </pc:picChg>
         <pc:picChg chg="add mod">
-          <ac:chgData name="Jack Bond" userId="d0613b4d9d68792d" providerId="LiveId" clId="{DAEA3D54-AD02-4E1B-A73A-AB467D915B21}" dt="2025-11-11T06:24:24.548" v="750" actId="1076"/>
+          <ac:chgData name="Jack Bond" userId="d0613b4d9d68792d" providerId="LiveId" clId="{DAEA3D54-AD02-4E1B-A73A-AB467D915B21}" dt="2025-11-11T18:16:30.668" v="778" actId="1076"/>
           <ac:picMkLst>
             <pc:docMk/>
             <pc:sldMk cId="3346064594" sldId="274"/>
@@ -233,7 +233,31 @@
           </ac:picMkLst>
         </pc:picChg>
         <pc:picChg chg="add mod">
-          <ac:chgData name="Jack Bond" userId="d0613b4d9d68792d" providerId="LiveId" clId="{DAEA3D54-AD02-4E1B-A73A-AB467D915B21}" dt="2025-11-11T05:30:12.034" v="672" actId="1076"/>
+          <ac:chgData name="Jack Bond" userId="d0613b4d9d68792d" providerId="LiveId" clId="{DAEA3D54-AD02-4E1B-A73A-AB467D915B21}" dt="2025-11-11T18:16:23.346" v="775" actId="1076"/>
+          <ac:picMkLst>
+            <pc:docMk/>
+            <pc:sldMk cId="3346064594" sldId="274"/>
+            <ac:picMk id="22" creationId="{AC6676AA-4E38-DA56-9001-F8B07B8F9ED1}"/>
+          </ac:picMkLst>
+        </pc:picChg>
+        <pc:picChg chg="add mod">
+          <ac:chgData name="Jack Bond" userId="d0613b4d9d68792d" providerId="LiveId" clId="{DAEA3D54-AD02-4E1B-A73A-AB467D915B21}" dt="2025-11-11T18:16:30.668" v="778" actId="1076"/>
+          <ac:picMkLst>
+            <pc:docMk/>
+            <pc:sldMk cId="3346064594" sldId="274"/>
+            <ac:picMk id="23" creationId="{0F476E08-2CA2-8817-86EB-A4F392CA124F}"/>
+          </ac:picMkLst>
+        </pc:picChg>
+        <pc:picChg chg="add mod">
+          <ac:chgData name="Jack Bond" userId="d0613b4d9d68792d" providerId="LiveId" clId="{DAEA3D54-AD02-4E1B-A73A-AB467D915B21}" dt="2025-11-11T18:16:30.668" v="778" actId="1076"/>
+          <ac:picMkLst>
+            <pc:docMk/>
+            <pc:sldMk cId="3346064594" sldId="274"/>
+            <ac:picMk id="24" creationId="{77F7ECA1-98F8-0519-D9A9-A31EA64BB926}"/>
+          </ac:picMkLst>
+        </pc:picChg>
+        <pc:picChg chg="add mod">
+          <ac:chgData name="Jack Bond" userId="d0613b4d9d68792d" providerId="LiveId" clId="{DAEA3D54-AD02-4E1B-A73A-AB467D915B21}" dt="2025-11-11T18:16:15.383" v="769" actId="1076"/>
           <ac:picMkLst>
             <pc:docMk/>
             <pc:sldMk cId="3346064594" sldId="274"/>
@@ -241,7 +265,7 @@
           </ac:picMkLst>
         </pc:picChg>
         <pc:picChg chg="add mod">
-          <ac:chgData name="Jack Bond" userId="d0613b4d9d68792d" providerId="LiveId" clId="{DAEA3D54-AD02-4E1B-A73A-AB467D915B21}" dt="2025-11-11T06:24:47.371" v="758" actId="1076"/>
+          <ac:chgData name="Jack Bond" userId="d0613b4d9d68792d" providerId="LiveId" clId="{DAEA3D54-AD02-4E1B-A73A-AB467D915B21}" dt="2025-11-11T18:16:22.197" v="774" actId="1076"/>
           <ac:picMkLst>
             <pc:docMk/>
             <pc:sldMk cId="3346064594" sldId="274"/>
@@ -249,7 +273,7 @@
           </ac:picMkLst>
         </pc:picChg>
         <pc:picChg chg="add mod">
-          <ac:chgData name="Jack Bond" userId="d0613b4d9d68792d" providerId="LiveId" clId="{DAEA3D54-AD02-4E1B-A73A-AB467D915B21}" dt="2025-11-11T06:24:22.388" v="749" actId="1076"/>
+          <ac:chgData name="Jack Bond" userId="d0613b4d9d68792d" providerId="LiveId" clId="{DAEA3D54-AD02-4E1B-A73A-AB467D915B21}" dt="2025-11-11T18:16:30.668" v="778" actId="1076"/>
           <ac:picMkLst>
             <pc:docMk/>
             <pc:sldMk cId="3346064594" sldId="274"/>
@@ -3239,7 +3263,7 @@
         </p:blipFill>
         <p:spPr bwMode="auto">
           <a:xfrm>
-            <a:off x="293914" y="2727543"/>
+            <a:off x="587056" y="483866"/>
             <a:ext cx="2499744" cy="1891001"/>
           </a:xfrm>
           <a:prstGeom prst="rect">
@@ -3286,8 +3310,8 @@
         </p:blipFill>
         <p:spPr>
           <a:xfrm>
-            <a:off x="749895" y="925833"/>
-            <a:ext cx="1110219" cy="1107618"/>
+            <a:off x="736351" y="3054657"/>
+            <a:ext cx="807434" cy="805542"/>
           </a:xfrm>
           <a:prstGeom prst="rect">
             <a:avLst/>
@@ -3323,7 +3347,7 @@
         </p:blipFill>
         <p:spPr bwMode="auto">
           <a:xfrm>
-            <a:off x="485304" y="5137295"/>
+            <a:off x="485303" y="5524537"/>
             <a:ext cx="2116963" cy="795637"/>
           </a:xfrm>
           <a:prstGeom prst="rect">
@@ -3370,7 +3394,7 @@
         </p:blipFill>
         <p:spPr bwMode="auto">
           <a:xfrm>
-            <a:off x="587056" y="6420254"/>
+            <a:off x="234228" y="7319536"/>
             <a:ext cx="1273058" cy="716095"/>
           </a:xfrm>
           <a:prstGeom prst="rect">
@@ -3417,7 +3441,7 @@
         </p:blipFill>
         <p:spPr bwMode="auto">
           <a:xfrm>
-            <a:off x="587056" y="7210028"/>
+            <a:off x="234228" y="8126984"/>
             <a:ext cx="1273058" cy="716095"/>
           </a:xfrm>
           <a:prstGeom prst="rect">
@@ -3469,6 +3493,147 @@
           <a:prstGeom prst="rect">
             <a:avLst/>
           </a:prstGeom>
+        </p:spPr>
+      </p:pic>
+      <p:pic>
+        <p:nvPicPr>
+          <p:cNvPr id="22" name="Picture 4" descr="494 Fancy Utensils Stock Vectors and Vector Art | Shutterstock">
+            <a:extLst>
+              <a:ext uri="{FF2B5EF4-FFF2-40B4-BE49-F238E27FC236}">
+                <a16:creationId xmlns:a16="http://schemas.microsoft.com/office/drawing/2014/main" id="{AC6676AA-4E38-DA56-9001-F8B07B8F9ED1}"/>
+              </a:ext>
+            </a:extLst>
+          </p:cNvPr>
+          <p:cNvPicPr>
+            <a:picLocks noChangeAspect="1" noChangeArrowheads="1"/>
+          </p:cNvPicPr>
+          <p:nvPr/>
+        </p:nvPicPr>
+        <p:blipFill>
+          <a:blip r:embed="rId5">
+            <a:extLst>
+              <a:ext uri="{28A0092B-C50C-407E-A947-70E740481C1C}">
+                <a14:useLocalDpi xmlns:a14="http://schemas.microsoft.com/office/drawing/2010/main" val="0"/>
+              </a:ext>
+            </a:extLst>
+          </a:blip>
+          <a:srcRect/>
+          <a:stretch>
+            <a:fillRect/>
+          </a:stretch>
+        </p:blipFill>
+        <p:spPr bwMode="auto">
+          <a:xfrm>
+            <a:off x="454242" y="4314127"/>
+            <a:ext cx="2116963" cy="795637"/>
+          </a:xfrm>
+          <a:prstGeom prst="rect">
+            <a:avLst/>
+          </a:prstGeom>
+          <a:noFill/>
+          <a:extLst>
+            <a:ext uri="{909E8E84-426E-40DD-AFC4-6F175D3DCCD1}">
+              <a14:hiddenFill xmlns:a14="http://schemas.microsoft.com/office/drawing/2010/main">
+                <a:solidFill>
+                  <a:srgbClr val="FFFFFF"/>
+                </a:solidFill>
+              </a14:hiddenFill>
+            </a:ext>
+          </a:extLst>
+        </p:spPr>
+      </p:pic>
+      <p:pic>
+        <p:nvPicPr>
+          <p:cNvPr id="23" name="Picture 6" descr="A Snapshot of American Knife History">
+            <a:extLst>
+              <a:ext uri="{FF2B5EF4-FFF2-40B4-BE49-F238E27FC236}">
+                <a16:creationId xmlns:a16="http://schemas.microsoft.com/office/drawing/2014/main" id="{0F476E08-2CA2-8817-86EB-A4F392CA124F}"/>
+              </a:ext>
+            </a:extLst>
+          </p:cNvPr>
+          <p:cNvPicPr>
+            <a:picLocks noChangeAspect="1" noChangeArrowheads="1"/>
+          </p:cNvPicPr>
+          <p:nvPr/>
+        </p:nvPicPr>
+        <p:blipFill>
+          <a:blip r:embed="rId6">
+            <a:extLst>
+              <a:ext uri="{28A0092B-C50C-407E-A947-70E740481C1C}">
+                <a14:useLocalDpi xmlns:a14="http://schemas.microsoft.com/office/drawing/2010/main" val="0"/>
+              </a:ext>
+            </a:extLst>
+          </a:blip>
+          <a:srcRect/>
+          <a:stretch>
+            <a:fillRect/>
+          </a:stretch>
+        </p:blipFill>
+        <p:spPr bwMode="auto">
+          <a:xfrm>
+            <a:off x="1934676" y="7247690"/>
+            <a:ext cx="1273058" cy="716095"/>
+          </a:xfrm>
+          <a:prstGeom prst="rect">
+            <a:avLst/>
+          </a:prstGeom>
+          <a:noFill/>
+          <a:extLst>
+            <a:ext uri="{909E8E84-426E-40DD-AFC4-6F175D3DCCD1}">
+              <a14:hiddenFill xmlns:a14="http://schemas.microsoft.com/office/drawing/2010/main">
+                <a:solidFill>
+                  <a:srgbClr val="FFFFFF"/>
+                </a:solidFill>
+              </a14:hiddenFill>
+            </a:ext>
+          </a:extLst>
+        </p:spPr>
+      </p:pic>
+      <p:pic>
+        <p:nvPicPr>
+          <p:cNvPr id="24" name="Picture 6" descr="A Snapshot of American Knife History">
+            <a:extLst>
+              <a:ext uri="{FF2B5EF4-FFF2-40B4-BE49-F238E27FC236}">
+                <a16:creationId xmlns:a16="http://schemas.microsoft.com/office/drawing/2014/main" id="{77F7ECA1-98F8-0519-D9A9-A31EA64BB926}"/>
+              </a:ext>
+            </a:extLst>
+          </p:cNvPr>
+          <p:cNvPicPr>
+            <a:picLocks noChangeAspect="1" noChangeArrowheads="1"/>
+          </p:cNvPicPr>
+          <p:nvPr/>
+        </p:nvPicPr>
+        <p:blipFill>
+          <a:blip r:embed="rId6">
+            <a:extLst>
+              <a:ext uri="{28A0092B-C50C-407E-A947-70E740481C1C}">
+                <a14:useLocalDpi xmlns:a14="http://schemas.microsoft.com/office/drawing/2010/main" val="0"/>
+              </a:ext>
+            </a:extLst>
+          </a:blip>
+          <a:srcRect/>
+          <a:stretch>
+            <a:fillRect/>
+          </a:stretch>
+        </p:blipFill>
+        <p:spPr bwMode="auto">
+          <a:xfrm>
+            <a:off x="1934676" y="8055138"/>
+            <a:ext cx="1273058" cy="716095"/>
+          </a:xfrm>
+          <a:prstGeom prst="rect">
+            <a:avLst/>
+          </a:prstGeom>
+          <a:noFill/>
+          <a:extLst>
+            <a:ext uri="{909E8E84-426E-40DD-AFC4-6F175D3DCCD1}">
+              <a14:hiddenFill xmlns:a14="http://schemas.microsoft.com/office/drawing/2010/main">
+                <a:solidFill>
+                  <a:srgbClr val="FFFFFF"/>
+                </a:solidFill>
+              </a14:hiddenFill>
+            </a:ext>
+          </a:extLst>
         </p:spPr>
       </p:pic>
     </p:spTree>

</xml_diff>